<commit_message>
docs: correct pitch deck for CLOCK IN (SKR stake claims, test count, roadmap dates)
Co-Authored-By: Claude Sonnet 5.5 <noreply@anthropic.com>
</commit_message>
<xml_diff>
--- a/demo/batak_pitch_deck.pptx
+++ b/demo/batak_pitch_deck.pptx
@@ -2029,7 +2029,7 @@
                 <a:ea typeface="Calibri" pitchFamily="34" charset="-122"/>
                 <a:cs typeface="Calibri" pitchFamily="34" charset="-120"/>
               </a:rPr>
-              <a:t>Monolith | Solana Mobile Hackathon</a:t>
+              <a:t>CLOCK IN | Solana Mobile Hackathon</a:t>
             </a:r>
             <a:endParaRPr lang="en-US" sz="1200" dirty="0"/>
           </a:p>
@@ -4258,7 +4258,7 @@
                 <a:ea typeface="Calibri" pitchFamily="34" charset="-122"/>
                 <a:cs typeface="Calibri" pitchFamily="34" charset="-120"/>
               </a:rPr>
-              <a:t>Devnet memo tx → proof of wallet approval for SKR stake</a:t>
+              <a:t>MWA-signed devnet memo tx on stake approval (prototype)</a:t>
             </a:r>
             <a:endParaRPr lang="en-US" sz="1000" dirty="0"/>
           </a:p>
@@ -4874,7 +4874,7 @@
                 <a:ea typeface="Calibri" pitchFamily="34" charset="-122"/>
                 <a:cs typeface="Calibri" pitchFamily="34" charset="-120"/>
               </a:rPr>
-              <a:t>Server validates claimSignature before creating room</a:t>
+              <a:t>On-chain stake verification &amp; escrow: roadmap</a:t>
             </a:r>
             <a:endParaRPr lang="en-US" sz="1000" dirty="0"/>
           </a:p>
@@ -7129,7 +7129,7 @@
                 <a:ea typeface="Calibri" pitchFamily="34" charset="-122"/>
                 <a:cs typeface="Calibri" pitchFamily="34" charset="-120"/>
               </a:rPr>
-              <a:t>Production server, real users</a:t>
+              <a:t>Production server, live</a:t>
             </a:r>
             <a:endParaRPr lang="en-US" sz="1000" dirty="0"/>
           </a:p>
@@ -7225,7 +7225,7 @@
                 <a:ea typeface="Georgia" pitchFamily="34" charset="-122"/>
                 <a:cs typeface="Georgia" pitchFamily="34" charset="-120"/>
               </a:rPr>
-              <a:t>94</a:t>
+              <a:t>136</a:t>
             </a:r>
             <a:endParaRPr lang="en-US" sz="3600" dirty="0"/>
           </a:p>
@@ -8233,7 +8233,7 @@
                 <a:ea typeface="Calibri" pitchFamily="34" charset="-122"/>
                 <a:cs typeface="Calibri" pitchFamily="34" charset="-120"/>
               </a:rPr>
-              <a:t>✅ SKR stake rooms</a:t>
+              <a:t>✅ SKR stake rooms (prototype)</a:t>
             </a:r>
             <a:endParaRPr lang="en-US" sz="1100" dirty="0"/>
           </a:p>
@@ -8368,7 +8368,7 @@
                 <a:ea typeface="Calibri" pitchFamily="34" charset="-122"/>
                 <a:cs typeface="Calibri" pitchFamily="34" charset="-120"/>
               </a:rPr>
-              <a:t>Q2 2026</a:t>
+              <a:t>Q4 2026</a:t>
             </a:r>
             <a:endParaRPr lang="en-US" sz="1600" dirty="0"/>
           </a:p>
@@ -8485,7 +8485,7 @@
                 <a:ea typeface="Calibri" pitchFamily="34" charset="-122"/>
                 <a:cs typeface="Calibri" pitchFamily="34" charset="-120"/>
               </a:rPr>
-              <a:t>💰 Real-money SKR prize pools</a:t>
+              <a:t>💰 On-chain SKR escrow &amp; prize pools</a:t>
             </a:r>
             <a:endParaRPr lang="en-US" sz="1100" dirty="0"/>
           </a:p>
@@ -8620,7 +8620,7 @@
                 <a:ea typeface="Calibri" pitchFamily="34" charset="-122"/>
                 <a:cs typeface="Calibri" pitchFamily="34" charset="-120"/>
               </a:rPr>
-              <a:t>Q3 2026</a:t>
+              <a:t>Q1 2027</a:t>
             </a:r>
             <a:endParaRPr lang="en-US" sz="1600" dirty="0"/>
           </a:p>

</xml_diff>

<commit_message>
docs: fix title/icon overlap on pitch deck slides 2 and 5
Co-Authored-By: Claude Sonnet 5.5 <noreply@anthropic.com>
</commit_message>
<xml_diff>
--- a/demo/batak_pitch_deck.pptx
+++ b/demo/batak_pitch_deck.pptx
@@ -2282,8 +2282,8 @@
         </p:nvSpPr>
         <p:spPr>
           <a:xfrm>
-            <a:off x="548640" y="1234440"/>
-            <a:ext cx="3840480" cy="457200"/>
+            <a:off x="1143000" y="1234440"/>
+            <a:ext cx="3246120" cy="457200"/>
           </a:xfrm>
           <a:prstGeom prst="rect">
             <a:avLst/>
@@ -2453,8 +2453,8 @@
         </p:nvSpPr>
         <p:spPr>
           <a:xfrm>
-            <a:off x="5029200" y="1234440"/>
-            <a:ext cx="3840480" cy="457200"/>
+            <a:off x="5623560" y="1234440"/>
+            <a:ext cx="3246120" cy="457200"/>
           </a:xfrm>
           <a:prstGeom prst="rect">
             <a:avLst/>
@@ -2624,8 +2624,8 @@
         </p:nvSpPr>
         <p:spPr>
           <a:xfrm>
-            <a:off x="548640" y="2971800"/>
-            <a:ext cx="3840480" cy="457200"/>
+            <a:off x="1143000" y="2971800"/>
+            <a:ext cx="3246120" cy="457200"/>
           </a:xfrm>
           <a:prstGeom prst="rect">
             <a:avLst/>
@@ -2795,8 +2795,8 @@
         </p:nvSpPr>
         <p:spPr>
           <a:xfrm>
-            <a:off x="5029200" y="2971800"/>
-            <a:ext cx="3840480" cy="457200"/>
+            <a:off x="5623560" y="2971800"/>
+            <a:ext cx="3246120" cy="457200"/>
           </a:xfrm>
           <a:prstGeom prst="rect">
             <a:avLst/>
@@ -6353,8 +6353,8 @@
         </p:nvSpPr>
         <p:spPr>
           <a:xfrm>
-            <a:off x="411480" y="3566160"/>
-            <a:ext cx="1737360" cy="411480"/>
+            <a:off x="822960" y="3566160"/>
+            <a:ext cx="1325880" cy="411480"/>
           </a:xfrm>
           <a:prstGeom prst="rect">
             <a:avLst/>
@@ -6492,8 +6492,8 @@
         </p:nvSpPr>
         <p:spPr>
           <a:xfrm>
-            <a:off x="2587752" y="3566160"/>
-            <a:ext cx="1737360" cy="411480"/>
+            <a:off x="2999232" y="3566160"/>
+            <a:ext cx="1325880" cy="411480"/>
           </a:xfrm>
           <a:prstGeom prst="rect">
             <a:avLst/>
@@ -6631,8 +6631,8 @@
         </p:nvSpPr>
         <p:spPr>
           <a:xfrm>
-            <a:off x="4764024" y="3566160"/>
-            <a:ext cx="1737360" cy="411480"/>
+            <a:off x="5175504" y="3566160"/>
+            <a:ext cx="1325880" cy="411480"/>
           </a:xfrm>
           <a:prstGeom prst="rect">
             <a:avLst/>
@@ -6770,8 +6770,8 @@
         </p:nvSpPr>
         <p:spPr>
           <a:xfrm>
-            <a:off x="6940296" y="3566160"/>
-            <a:ext cx="1737360" cy="411480"/>
+            <a:off x="7351776" y="3566160"/>
+            <a:ext cx="1325880" cy="411480"/>
           </a:xfrm>
           <a:prstGeom prst="rect">
             <a:avLst/>

</xml_diff>

<commit_message>
docs(deck): correct Merkle tree size and metadata hosting, test count, networks, roadmap
Co-Authored-By: Claude Sonnet 5.5 <noreply@anthropic.com>
</commit_message>
<xml_diff>
--- a/demo/batak_pitch_deck.pptx
+++ b/demo/batak_pitch_deck.pptx
@@ -4513,7 +4513,7 @@
                 <a:ea typeface="Calibri" pitchFamily="34" charset="-122"/>
                 <a:cs typeface="Calibri" pitchFamily="34" charset="-120"/>
               </a:rPr>
-              <a:t>Merkle tree: EQPVVrkCnP... (14-depth, 16K capacity)</a:t>
+              <a:t>Merkle tree: EQPVVrkCnP... (depth 5, 32 leaves, budgeted)</a:t>
             </a:r>
             <a:endParaRPr lang="en-US" sz="1000" dirty="0"/>
           </a:p>
@@ -4566,7 +4566,7 @@
                 <a:ea typeface="Calibri" pitchFamily="34" charset="-122"/>
                 <a:cs typeface="Calibri" pitchFamily="34" charset="-120"/>
               </a:rPr>
-              <a:t>IPFS metadata via nft.storage</a:t>
+              <a:t>Trophy metadata served from batakci.xyz/nft</a:t>
             </a:r>
             <a:endParaRPr lang="en-US" sz="1000" dirty="0"/>
           </a:p>
@@ -4619,7 +4619,7 @@
                 <a:ea typeface="Calibri" pitchFamily="34" charset="-122"/>
                 <a:cs typeface="Calibri" pitchFamily="34" charset="-120"/>
               </a:rPr>
-              <a:t>Tournament winners mint trophy to their wallet automatically</a:t>
+              <a:t>Winners get the trophy automatically (2 per wallet/day)</a:t>
             </a:r>
             <a:endParaRPr lang="en-US" sz="1000" dirty="0"/>
           </a:p>
@@ -4927,7 +4927,7 @@
                 <a:ea typeface="Calibri" pitchFamily="34" charset="-122"/>
                 <a:cs typeface="Calibri" pitchFamily="34" charset="-120"/>
               </a:rPr>
-              <a:t>Separate mainnet (SKR) vs devnet (game) — no cross-contamination</a:t>
+              <a:t>Game &amp; auth on devnet; cNFTs and SKR balance on mainnet</a:t>
             </a:r>
             <a:endParaRPr lang="en-US" sz="1000" dirty="0"/>
           </a:p>
@@ -7225,7 +7225,7 @@
                 <a:ea typeface="Georgia" pitchFamily="34" charset="-122"/>
                 <a:cs typeface="Georgia" pitchFamily="34" charset="-120"/>
               </a:rPr>
-              <a:t>136</a:t>
+              <a:t>136+</a:t>
             </a:r>
             <a:endParaRPr lang="en-US" sz="3600" dirty="0"/>
           </a:p>
@@ -7303,7 +7303,7 @@
                 <a:ea typeface="Calibri" pitchFamily="34" charset="-122"/>
                 <a:cs typeface="Calibri" pitchFamily="34" charset="-120"/>
               </a:rPr>
-              <a:t>0 failures — robust game logic</a:t>
+              <a:t>Auth, ownership &amp; mint-budget suites</a:t>
             </a:r>
             <a:endParaRPr lang="en-US" sz="1000" dirty="0"/>
           </a:p>
@@ -8194,7 +8194,7 @@
                 <a:ea typeface="Calibri" pitchFamily="34" charset="-122"/>
                 <a:cs typeface="Calibri" pitchFamily="34" charset="-120"/>
               </a:rPr>
-              <a:t>✅ cNFT trophy minting</a:t>
+              <a:t>✅ cNFT minting (tested on Seeker)</a:t>
             </a:r>
             <a:endParaRPr lang="en-US" sz="1100" dirty="0"/>
           </a:p>
@@ -8524,7 +8524,7 @@
                 <a:ea typeface="Calibri" pitchFamily="34" charset="-122"/>
                 <a:cs typeface="Calibri" pitchFamily="34" charset="-120"/>
               </a:rPr>
-              <a:t>📊 Advanced stats &amp; replays</a:t>
+              <a:t>🌳 Larger Merkle tree for launch</a:t>
             </a:r>
             <a:endParaRPr lang="en-US" sz="1100" dirty="0"/>
           </a:p>

</xml_diff>